<commit_message>
Make the Programme page agree with itself
Two things an admin demo would have shown:

- "Take-up by project" said "No enrolments yet" directly under a card
  reading 1 enrolment. Take-up only counts catalogue projects, and an
  own-idea project has no catalogue entry. The empty state now says so.
- The seeded reflection and help request quoted 54 unwritten practices;
  the page computes 53 from the same workbook. Corrected, along with the
  deck.

Co-Authored-By: Claude Opus 5 <noreply@anthropic.com>
</commit_message>
<xml_diff>
--- a/docs/IMPACT-Release-1-Demo.pptx
+++ b/docs/IMPACT-Release-1-Demo.pptx
@@ -603,7 +603,7 @@
           <a:p>
             <a:r>
               <a:rPr lang="en-US" dirty="0"/>
-              <a:t>The 54 blank practice pages are now a visible number on the Staff page. That is content work for coaches, not code.</a:t>
+              <a:t>The 53 blank practice pages are now a visible number on the Programme page. That is content work for coaches, not code.</a:t>
             </a:r>
             <a:endParaRPr lang="en-US" dirty="0"/>
           </a:p>
@@ -2595,7 +2595,7 @@
                 <a:ea typeface="Arial" pitchFamily="34" charset="-122"/>
                 <a:cs typeface="Arial" pitchFamily="34" charset="-120"/>
               </a:rPr>
-              <a:t>70 → 16</a:t>
+              <a:t>69 → 16</a:t>
             </a:r>
             <a:endParaRPr lang="en-US" sz="2400" dirty="0"/>
           </a:p>
@@ -2676,7 +2676,7 @@
                 <a:ea typeface="Arial" pitchFamily="34" charset="-122"/>
                 <a:cs typeface="Arial" pitchFamily="34" charset="-120"/>
               </a:rPr>
-              <a:t>54 were blank pages. Now hidden from students, surfaced to coaches who can write them.</a:t>
+              <a:t>53 were blank pages. Now hidden from students, surfaced to coaches who can write them.</a:t>
             </a:r>
             <a:endParaRPr lang="en-US" sz="1150" dirty="0"/>
           </a:p>
@@ -4326,7 +4326,7 @@
                 <a:ea typeface="Arial" pitchFamily="34" charset="-122"/>
                 <a:cs typeface="Arial" pitchFamily="34" charset="-120"/>
               </a:rPr>
-              <a:t>The 54 blank practices, and a real brief on each catalogue entry. Content work with the coaches, not code.</a:t>
+              <a:t>The 53 blank practices, and a real brief on each catalogue entry. Content work with the coaches, not code.</a:t>
             </a:r>
             <a:endParaRPr lang="en-US" sz="1000" dirty="0"/>
           </a:p>
@@ -5159,7 +5159,7 @@
                 <a:ea typeface="Arial" pitchFamily="34" charset="-122"/>
                 <a:cs typeface="Arial" pitchFamily="34" charset="-120"/>
               </a:rPr>
-              <a:t>54 practice pages and 92 catalogue briefs. Blocks Release 3.</a:t>
+              <a:t>53 practice pages and 92 catalogue briefs. Blocks Release 3.</a:t>
             </a:r>
             <a:endParaRPr lang="en-US" sz="1000" dirty="0"/>
           </a:p>

</xml_diff>